<commit_message>
notes: add PIM definition to presenter notes
</commit_message>
<xml_diff>
--- a/presentations/p01/codefest_p01_bao_nguyen.pptx
+++ b/presentations/p01/codefest_p01_bao_nguyen.pptx
@@ -568,6 +568,22 @@
           <a:p>
             <a:r>
               <a:t>Total target: ~60 seconds.</a:t>
+            </a:r>
+          </a:p>
+          <a:p/>
+          <a:p>
+            <a:r>
+              <a:t>---</a:t>
+            </a:r>
+          </a:p>
+          <a:p>
+            <a:r>
+              <a:t>DEFINITIONS</a:t>
+            </a:r>
+          </a:p>
+          <a:p>
+            <a:r>
+              <a:t>PIM = Processing-In-Memory. A chip design where the compute units are placed physically next to the memory, instead of the usual CPU→bus→RAM setup. Normally the CPU fetches pixel data across a slow memory bus, does a tiny bit of math, then waits for more data — that's why K-Means is memory-bound on CPU (46% of runtime is just waiting). With a PIM chiplet, the distance math (subtract, square, accumulate) happens right where the pixels already live in HBM3 memory. No bus trip, no waiting. That's where the 16 TB/s bandwidth and the 62× speedup come from. In the diagram it's the pink dashed box — the Compute Engine and On-Chip Memory are co-located on the same chiplet, connected to the CPU via UCIe.</a:t>
             </a:r>
           </a:p>
           <a:p/>

</xml_diff>

<commit_message>
slide: add specific tech to 'how others do it' section
</commit_message>
<xml_diff>
--- a/presentations/p01/codefest_p01_bao_nguyen.pptx
+++ b/presentations/p01/codefest_p01_bao_nguyen.pptx
@@ -3898,7 +3898,7 @@
                   <a:srgbClr val="DDDDDD"/>
                 </a:solidFill>
               </a:rPr>
-              <a:t>  • CPU takes ~9 sec/image using &lt;1% of its power</a:t>
+              <a:t>  • CPU: scikit-learn + OpenBLAS — ~9 sec/image, &lt;1% utilization</a:t>
             </a:r>
           </a:p>
           <a:p>
@@ -3913,7 +3913,37 @@
                   <a:srgbClr val="DDDDDD"/>
                 </a:solidFill>
               </a:rPr>
-              <a:t>  • 46% of runtime spent waiting for data from memory</a:t>
+              <a:t>  • GPU: NVIDIA cuML / CUDA — fast but general-purpose, not K-Means specific</a:t>
+            </a:r>
+          </a:p>
+          <a:p>
+            <a:pPr>
+              <a:spcBef>
+                <a:spcPts val="100"/>
+              </a:spcBef>
+            </a:pPr>
+            <a:r>
+              <a:rPr sz="800" b="0">
+                <a:solidFill>
+                  <a:srgbClr val="DDDDDD"/>
+                </a:solidFill>
+              </a:rPr>
+              <a:t>  • FPGA: AMD Artix-7 pipelined designs — rigid, device-specific</a:t>
+            </a:r>
+          </a:p>
+          <a:p>
+            <a:pPr>
+              <a:spcBef>
+                <a:spcPts val="100"/>
+              </a:spcBef>
+            </a:pPr>
+            <a:r>
+              <a:rPr sz="800" b="0">
+                <a:solidFill>
+                  <a:srgbClr val="DDDDDD"/>
+                </a:solidFill>
+              </a:rPr>
+              <a:t>  • No near-memory PIM accelerator exists for K-Means</a:t>
             </a:r>
           </a:p>
           <a:p>

</xml_diff>